<commit_message>
Laboratoire 10 : version simple
</commit_message>
<xml_diff>
--- a/lab10/presentation.pptx
+++ b/lab10/presentation.pptx
@@ -4,7 +4,12 @@
   <p:sldMasterIdLst>
     <p:sldMasterId id="2147483648" r:id="rId1"/>
   </p:sldMasterIdLst>
-  <p:sldIdLst/>
+  <p:sldIdLst>
+    <p:sldId id="256" r:id="rId2"/>
+    <p:sldId id="257" r:id="rId3"/>
+    <p:sldId id="258" r:id="rId4"/>
+    <p:sldId id="259" r:id="rId5"/>
+  </p:sldIdLst>
   <p:sldSz cx="9144000" cy="5143500" type="screen16x9"/>
   <p:notesSz cx="6858000" cy="9144000"/>
   <p:defaultTextStyle>
@@ -3069,6 +3074,325 @@
     </p:otherStyle>
   </p:txStyles>
 </p:sldMaster>
+</file>
+
+<file path=ppt/slides/slide1.xml><?xml version="1.0" encoding="utf-8"?>
+<p:sld xmlns:a="http://schemas.openxmlformats.org/drawingml/2006/main" xmlns:r="http://schemas.openxmlformats.org/officeDocument/2006/relationships" xmlns:p="http://schemas.openxmlformats.org/presentationml/2006/main">
+  <p:cSld>
+    <p:spTree>
+      <p:nvGrpSpPr>
+        <p:cNvPr id="1" name=""/>
+        <p:cNvGrpSpPr/>
+        <p:nvPr/>
+      </p:nvGrpSpPr>
+      <p:grpSpPr>
+        <a:xfrm>
+          <a:off x="0" y="0"/>
+          <a:ext cx="0" cy="0"/>
+          <a:chOff x="0" y="0"/>
+          <a:chExt cx="0" cy="0"/>
+        </a:xfrm>
+      </p:grpSpPr>
+      <p:sp>
+        <p:nvSpPr>
+          <p:cNvPr id="2" name="Title 1"/>
+          <p:cNvSpPr>
+            <a:spLocks noGrp="1"/>
+          </p:cNvSpPr>
+          <p:nvPr>
+            <p:ph type="ctrTitle"/>
+          </p:nvPr>
+        </p:nvSpPr>
+        <p:spPr>
+          <a:xfrm>
+            <a:off x="685800" y="1597819"/>
+            <a:ext cx="7772400" cy="1102519"/>
+          </a:xfrm>
+        </p:spPr>
+        <p:txBody>
+          <a:bodyPr/>
+          <a:lstStyle/>
+          <a:p>
+            <a:pPr lvl="0" indent="0" marL="0">
+              <a:buNone/>
+            </a:pPr>
+            <a:r>
+              <a:rPr/>
+              <a:t>vi</a:t>
+            </a:r>
+          </a:p>
+        </p:txBody>
+      </p:sp>
+      <p:sp>
+        <p:nvSpPr>
+          <p:cNvPr id="3" name="Subtitle 2"/>
+          <p:cNvSpPr>
+            <a:spLocks noGrp="1"/>
+          </p:cNvSpPr>
+          <p:nvPr>
+            <p:ph idx="1" type="subTitle"/>
+          </p:nvPr>
+        </p:nvSpPr>
+        <p:spPr>
+          <a:xfrm>
+            <a:off x="1371600" y="2914650"/>
+            <a:ext cx="6400800" cy="1314450"/>
+          </a:xfrm>
+        </p:spPr>
+        <p:txBody>
+          <a:bodyPr/>
+          <a:lstStyle/>
+          <a:p>
+            <a:pPr lvl="0" indent="0" marL="0">
+              <a:buNone/>
+            </a:pPr>
+            <a:br/>
+            <a:br/>
+            <a:r>
+              <a:rPr/>
+              <a:t>Votre Nom</a:t>
+            </a:r>
+          </a:p>
+        </p:txBody>
+      </p:sp>
+      <p:sp>
+        <p:nvSpPr>
+          <p:cNvPr id="4" name="Date Placeholder 3"/>
+          <p:cNvSpPr>
+            <a:spLocks noGrp="1"/>
+          </p:cNvSpPr>
+          <p:nvPr>
+            <p:ph idx="10" sz="half" type="dt"/>
+          </p:nvPr>
+        </p:nvSpPr>
+        <p:spPr/>
+        <p:txBody>
+          <a:bodyPr/>
+          <a:lstStyle/>
+          <a:p>
+            <a:pPr lvl="0" indent="0" marL="0">
+              <a:buNone/>
+            </a:pPr>
+            <a:r>
+              <a:rPr/>
+              <a:t>LISSOM BAYEM ODILON</a:t>
+            </a:r>
+          </a:p>
+        </p:txBody>
+      </p:sp>
+    </p:spTree>
+  </p:cSld>
+</p:sld>
+</file>
+
+<file path=ppt/slides/slide2.xml><?xml version="1.0" encoding="utf-8"?>
+<p:sld xmlns:a="http://schemas.openxmlformats.org/drawingml/2006/main" xmlns:r="http://schemas.openxmlformats.org/officeDocument/2006/relationships" xmlns:p="http://schemas.openxmlformats.org/presentationml/2006/main">
+  <p:cSld>
+    <p:spTree>
+      <p:nvGrpSpPr>
+        <p:cNvPr id="1" name=""/>
+        <p:cNvGrpSpPr/>
+        <p:nvPr/>
+      </p:nvGrpSpPr>
+      <p:grpSpPr>
+        <a:xfrm>
+          <a:off x="0" y="0"/>
+          <a:ext cx="0" cy="0"/>
+          <a:chOff x="0" y="0"/>
+          <a:chExt cx="0" cy="0"/>
+        </a:xfrm>
+      </p:grpSpPr>
+      <p:sp>
+        <p:nvSpPr>
+          <p:cNvPr id="3" name="Content Placeholder 2"/>
+          <p:cNvSpPr>
+            <a:spLocks noGrp="1"/>
+          </p:cNvSpPr>
+          <p:nvPr>
+            <p:ph idx="1"/>
+          </p:nvPr>
+        </p:nvSpPr>
+        <p:spPr/>
+        <p:txBody>
+          <a:bodyPr/>
+          <a:lstStyle/>
+          <a:p>
+            <a:pPr lvl="0" indent="0" marL="0">
+              <a:buNone/>
+            </a:pPr>
+            <a:r>
+              <a:rPr/>
+              <a:t>% </a:t>
+            </a:r>
+          </a:p>
+        </p:txBody>
+      </p:sp>
+    </p:spTree>
+  </p:cSld>
+</p:sld>
+</file>
+
+<file path=ppt/slides/slide3.xml><?xml version="1.0" encoding="utf-8"?>
+<p:sld xmlns:a="http://schemas.openxmlformats.org/drawingml/2006/main" xmlns:r="http://schemas.openxmlformats.org/officeDocument/2006/relationships" xmlns:p="http://schemas.openxmlformats.org/presentationml/2006/main">
+  <p:cSld>
+    <p:spTree>
+      <p:nvGrpSpPr>
+        <p:cNvPr id="1" name=""/>
+        <p:cNvGrpSpPr/>
+        <p:nvPr/>
+      </p:nvGrpSpPr>
+      <p:grpSpPr>
+        <a:xfrm>
+          <a:off x="0" y="0"/>
+          <a:ext cx="0" cy="0"/>
+          <a:chOff x="0" y="0"/>
+          <a:chExt cx="0" cy="0"/>
+        </a:xfrm>
+      </p:grpSpPr>
+      <p:sp>
+        <p:nvSpPr>
+          <p:cNvPr id="2" name="Title 1"/>
+          <p:cNvSpPr>
+            <a:spLocks noGrp="1"/>
+          </p:cNvSpPr>
+          <p:nvPr>
+            <p:ph type="title"/>
+          </p:nvPr>
+        </p:nvSpPr>
+        <p:spPr/>
+        <p:txBody>
+          <a:bodyPr/>
+          <a:lstStyle/>
+          <a:p>
+            <a:pPr lvl="0" indent="0" marL="0">
+              <a:buNone/>
+            </a:pPr>
+            <a:r>
+              <a:rPr/>
+              <a:t>Objectif</a:t>
+            </a:r>
+          </a:p>
+        </p:txBody>
+      </p:sp>
+      <p:sp>
+        <p:nvSpPr>
+          <p:cNvPr id="3" name="Content Placeholder 2"/>
+          <p:cNvSpPr>
+            <a:spLocks noGrp="1"/>
+          </p:cNvSpPr>
+          <p:nvPr>
+            <p:ph idx="1"/>
+          </p:nvPr>
+        </p:nvSpPr>
+        <p:spPr/>
+        <p:txBody>
+          <a:bodyPr/>
+          <a:lstStyle/>
+          <a:p>
+            <a:pPr lvl="0" indent="0" marL="0">
+              <a:buNone/>
+            </a:pPr>
+            <a:r>
+              <a:rPr/>
+              <a:t>Apprendre vi.</a:t>
+            </a:r>
+          </a:p>
+        </p:txBody>
+      </p:sp>
+    </p:spTree>
+  </p:cSld>
+</p:sld>
+</file>
+
+<file path=ppt/slides/slide4.xml><?xml version="1.0" encoding="utf-8"?>
+<p:sld xmlns:a="http://schemas.openxmlformats.org/drawingml/2006/main" xmlns:r="http://schemas.openxmlformats.org/officeDocument/2006/relationships" xmlns:p="http://schemas.openxmlformats.org/presentationml/2006/main">
+  <p:cSld>
+    <p:spTree>
+      <p:nvGrpSpPr>
+        <p:cNvPr id="1" name=""/>
+        <p:cNvGrpSpPr/>
+        <p:nvPr/>
+      </p:nvGrpSpPr>
+      <p:grpSpPr>
+        <a:xfrm>
+          <a:off x="0" y="0"/>
+          <a:ext cx="0" cy="0"/>
+          <a:chOff x="0" y="0"/>
+          <a:chExt cx="0" cy="0"/>
+        </a:xfrm>
+      </p:grpSpPr>
+      <p:sp>
+        <p:nvSpPr>
+          <p:cNvPr id="2" name="Title 1"/>
+          <p:cNvSpPr>
+            <a:spLocks noGrp="1"/>
+          </p:cNvSpPr>
+          <p:nvPr>
+            <p:ph type="title"/>
+          </p:nvPr>
+        </p:nvSpPr>
+        <p:spPr/>
+        <p:txBody>
+          <a:bodyPr/>
+          <a:lstStyle/>
+          <a:p>
+            <a:pPr lvl="0" indent="0" marL="0">
+              <a:buNone/>
+            </a:pPr>
+            <a:r>
+              <a:rPr/>
+              <a:t>Commandes</a:t>
+            </a:r>
+          </a:p>
+        </p:txBody>
+      </p:sp>
+      <p:sp>
+        <p:nvSpPr>
+          <p:cNvPr id="3" name="Content Placeholder 2"/>
+          <p:cNvSpPr>
+            <a:spLocks noGrp="1"/>
+          </p:cNvSpPr>
+          <p:nvPr>
+            <p:ph idx="1"/>
+          </p:nvPr>
+        </p:nvSpPr>
+        <p:spPr/>
+        <p:txBody>
+          <a:bodyPr/>
+          <a:lstStyle/>
+          <a:p>
+            <a:pPr lvl="0"/>
+            <a:r>
+              <a:rPr/>
+              <a:t>i : insertion</a:t>
+            </a:r>
+          </a:p>
+          <a:p>
+            <a:pPr lvl="0"/>
+            <a:r>
+              <a:rPr/>
+              <a:t>i : insertion</a:t>
+            </a:r>
+          </a:p>
+          <a:p>
+            <a:pPr lvl="0"/>
+            <a:r>
+              <a:rPr/>
+              <a:t>Esc : mode commande</a:t>
+            </a:r>
+          </a:p>
+          <a:p>
+            <a:pPr lvl="0"/>
+            <a:r>
+              <a:rPr/>
+              <a:t>:wq : sauver et quitter</a:t>
+            </a:r>
+          </a:p>
+        </p:txBody>
+      </p:sp>
+    </p:spTree>
+  </p:cSld>
+</p:sld>
 </file>
 
 <file path=ppt/theme/theme1.xml><?xml version="1.0" encoding="utf-8"?>

</xml_diff>